<commit_message>
Carrusel v2: iconos de los chips y chapas con fondo transparente; la chapa de Jugar dentro del lienzo
Co-Authored-By: Claude Fable 5.1 <noreply@anthropic.com>
Claude-Session: https://claude.ai/code/session_01SJQkm3gTKwBC1nx4r9bYD9
</commit_message>
<xml_diff>
--- a/assets/redes/pokedoc-carrusel-v2.pptx
+++ b/assets/redes/pokedoc-carrusel-v2.pptx
@@ -4744,8 +4744,8 @@
         </p:nvSpPr>
         <p:spPr>
           <a:xfrm>
-            <a:off x="5334000" y="10096500"/>
-            <a:ext cx="4667250" cy="1047750"/>
+            <a:off x="4762500" y="10096500"/>
+            <a:ext cx="4857750" cy="1047750"/>
           </a:xfrm>
           <a:prstGeom prst="roundRect">
             <a:avLst>
@@ -4788,7 +4788,7 @@
         </p:blipFill>
         <p:spPr>
           <a:xfrm>
-            <a:off x="5505450" y="10287000"/>
+            <a:off x="4933950" y="10287000"/>
             <a:ext cx="666750" cy="666750"/>
           </a:xfrm>
           <a:prstGeom prst="rect">
@@ -4804,8 +4804,8 @@
         </p:nvSpPr>
         <p:spPr>
           <a:xfrm>
-            <a:off x="6324600" y="10287000"/>
-            <a:ext cx="3524250" cy="400050"/>
+            <a:off x="5753100" y="10287000"/>
+            <a:ext cx="3714750" cy="400050"/>
           </a:xfrm>
           <a:prstGeom prst="rect">
             <a:avLst/>
@@ -4846,8 +4846,8 @@
         </p:nvSpPr>
         <p:spPr>
           <a:xfrm>
-            <a:off x="6324600" y="10687050"/>
-            <a:ext cx="3524250" cy="323850"/>
+            <a:off x="5753100" y="10687050"/>
+            <a:ext cx="3714750" cy="323850"/>
           </a:xfrm>
           <a:prstGeom prst="rect">
             <a:avLst/>

</xml_diff>